<commit_message>
Galderma Q3 2026: tie the title to valuation, clarify Chart 1 categories
Title now links the beat and raise to upgrades lowering the P/E. Chart 1
caption and footnote describe the bars as Galderma product categories
instead of "operating KPIs".

Co-Authored-By: Claude Opus 5.5 <noreply@anthropic.com>
Claude-Session: https://claude.ai/code/session_013Tac4JRHtmNMagmHSSo5r2
</commit_message>
<xml_diff>
--- a/reports/GALD_Q3_2026/Earnings_Update_GALD_Q32026.pptx
+++ b/reports/GALD_Q3_2026/Earnings_Update_GALD_Q32026.pptx
@@ -1254,7 +1254,7 @@
                 <a:ea typeface="Nunito" pitchFamily="34" charset="-122"/>
                 <a:cs typeface="Nunito" pitchFamily="34" charset="-120"/>
               </a:rPr>
-              <a:t>Galderma Q3 2026: beat and raise, now upgrades must follow</a:t>
+              <a:t>Galderma Q3 2026: beat and raise, upgrades to lower the P/E</a:t>
             </a:r>
             <a:endParaRPr lang="en-US" sz="1700" dirty="0"/>
           </a:p>
@@ -2500,7 +2500,7 @@
                 <a:ea typeface="Nunito" pitchFamily="34" charset="-122"/>
                 <a:cs typeface="Nunito" pitchFamily="34" charset="-120"/>
               </a:rPr>
-              <a:t>Year-on-year growth at constant currency, % · group sales USD 1,632m vs. consensus USD 1,552m (+5.1%) · categories are operating KPIs</a:t>
+              <a:t>Year-on-year growth at constant currency, % · group sales USD 1,632m vs. consensus USD 1,552m (+5.1%) · Galderma product categories</a:t>
             </a:r>
             <a:endParaRPr lang="en-US" sz="720" dirty="0"/>
           </a:p>

</xml_diff>

<commit_message>
Galderma Q3 2026: growth bridge as Chart 1, new title, +6% share price
- Chart 1 is now a bridge of each product category's contribution to Q3
  group growth at constant currency (Appendix 2 weights, Q3 2025 USD 1,289m).
- Title: "Galderma Q3 2026: a beat, a raise and a rally".
- Results-day move set to +6% on the 21 October close: Chart 2 last point,
  P/E (46.7x) and the related figures in the text updated.

Co-Authored-By: Claude Opus 5.5 <noreply@anthropic.com>
Claude-Session: https://claude.ai/code/session_013Tac4JRHtmNMagmHSSo5r2
</commit_message>
<xml_diff>
--- a/reports/GALD_Q3_2026/Earnings_Update_GALD_Q32026.pptx
+++ b/reports/GALD_Q3_2026/Earnings_Update_GALD_Q32026.pptx
@@ -1254,7 +1254,7 @@
                 <a:ea typeface="Nunito" pitchFamily="34" charset="-122"/>
                 <a:cs typeface="Nunito" pitchFamily="34" charset="-120"/>
               </a:rPr>
-              <a:t>Galderma Q3 2026: beat and raise, upgrades to lower the P/E</a:t>
+              <a:t>Galderma Q3 2026: a beat, a raise and a rally</a:t>
             </a:r>
             <a:endParaRPr lang="en-US" sz="1700" dirty="0"/>
           </a:p>
@@ -1762,7 +1762,7 @@
                 <a:ea typeface="Nunito" pitchFamily="34" charset="-122"/>
                 <a:cs typeface="Nunito" pitchFamily="34" charset="-120"/>
               </a:rPr>
-              <a:t>46.1x this year’s consensus earnings with the shares 2% below their record: upgrades must now do the work.</a:t>
+              <a:t>46.7x this year’s consensus earnings with the shares just below their record: upgrades must now do the work.</a:t>
             </a:r>
             <a:endParaRPr lang="en-US" sz="870" dirty="0"/>
           </a:p>
@@ -2458,7 +2458,7 @@
                 <a:ea typeface="Nunito" pitchFamily="34" charset="-122"/>
                 <a:cs typeface="Nunito" pitchFamily="34" charset="-120"/>
               </a:rPr>
-              <a:t> · GALD: Q3 2026 sales growth by category at constant currency</a:t>
+              <a:t> · GALD: contribution to Q3 2026 group growth (bridge)</a:t>
             </a:r>
             <a:endParaRPr lang="en-US" sz="950" dirty="0"/>
           </a:p>
@@ -2500,7 +2500,7 @@
                 <a:ea typeface="Nunito" pitchFamily="34" charset="-122"/>
                 <a:cs typeface="Nunito" pitchFamily="34" charset="-120"/>
               </a:rPr>
-              <a:t>Year-on-year growth at constant currency, % · group sales USD 1,632m vs. consensus USD 1,552m (+5.1%) · Galderma product categories</a:t>
+              <a:t>Contribution to group growth at constant currency, pp · weighted by Q3 2025 sales mix (USD 1,289m) · sum 26.2pp vs. 26.0% reported (rounding)</a:t>
             </a:r>
             <a:endParaRPr lang="en-US" sz="720" dirty="0"/>
           </a:p>
@@ -2566,7 +2566,7 @@
                 <a:ea typeface="Nunito" pitchFamily="34" charset="-122"/>
                 <a:cs typeface="Nunito" pitchFamily="34" charset="-120"/>
               </a:rPr>
-              <a:t>Every category grew, three of four at a double-digit rate. Neuromodulators were helped by US shipments shifted from Q2, which flatters the quarter, but Dysport share gains and the Relfydess roll-out, approved in 37 markets, are structural. Fillers and biostimulators, at 4.8%, are the soft spot: the market is weak and last year included the Sculptra launch in China.</a:t>
+              <a:t>Therapeutic dermatology added 14.4 points of the 26.0% growth, but neuromodulators (6.5), dermatological skincare (4.2) and fillers (1.1) delivered close to 12 points. Neuromodulators were helped by US shipments shifted from Q2, which flatters the quarter. Fillers and biostimulators, up only 4.8%, remain the soft spot after last year’s Sculptra launch in China.</a:t>
             </a:r>
             <a:endParaRPr lang="en-US" sz="870" dirty="0"/>
           </a:p>
@@ -2647,7 +2647,7 @@
                 <a:ea typeface="Nunito" pitchFamily="34" charset="-122"/>
                 <a:cs typeface="Nunito" pitchFamily="34" charset="-120"/>
               </a:rPr>
-              <a:t>We stay positive on Galderma. Our base case is 2026 sales growth of about 23% at constant currency, a core EBITDA margin near 26% and consensus earnings per share of USD 4.80 edging higher after the raise. The debate has moved from whether Galderma can grow to whether it can hold the pace through generic erosion, the Relfydess delay and the ZO Skin Health integration. With the shares up 4.2% on the day and 2% below their June record, the easy re-rating is done. The next test is the full-year release in early 2027.</a:t>
+              <a:t>We stay positive on Galderma. Our base case is 2026 sales growth of about 23% at constant currency, a core EBITDA margin near 26% and consensus earnings per share of USD 4.80 edging higher after the raise. The debate has moved from whether Galderma can grow to whether it can hold the pace through generic erosion, the Relfydess delay and the ZO Skin Health integration. With the shares up 6% on the day and just below their June record, the easy re-rating is done. The next test is the full-year release in early 2027.</a:t>
             </a:r>
             <a:endParaRPr lang="en-US" sz="870" dirty="0"/>
           </a:p>
@@ -3367,7 +3367,7 @@
                 <a:ea typeface="Nunito" pitchFamily="34" charset="-122"/>
                 <a:cs typeface="Nunito" pitchFamily="34" charset="-120"/>
               </a:rPr>
-              <a:t>GALD SW Equity, daily · consensus current-year EPS (USD), rolls each January · 200-day MA · log scale · last price after the release</a:t>
+              <a:t>GALD SW Equity, daily · consensus current-year EPS (USD), rolls each January · 200-day MA · log scale · last price: 21 October close +6%</a:t>
             </a:r>
             <a:endParaRPr lang="en-US" sz="720" dirty="0"/>
           </a:p>
@@ -3433,7 +3433,7 @@
                 <a:ea typeface="Nunito" pitchFamily="34" charset="-122"/>
                 <a:cs typeface="Nunito" pitchFamily="34" charset="-120"/>
               </a:rPr>
-              <a:t>The shares trade at 46.1x consensus 2026 earnings, 4% below the 48.2x average since May 2024 and close to the 44.0x average of 2026; the long-run figure is inflated by late-2025 readings on an ageing 2025 base. Consensus 2026 earnings per share has risen 6.4% since January and 4.3% since the H1 results, while the price was flat between the releases until today’s 4.2% gain: the stock de-rated from 46.4x to 44.0x before the print. The price sits 12% above its 200-day average. At about 33x 2027 analyst estimates, upgrades, not the multiple, drive the next leg.</a:t>
+              <a:t>The shares trade at 46.7x consensus 2026 earnings, 3% below the 48.2x average since May 2024 and close to the 44.0x average of 2026; the long-run figure is inflated by late-2025 readings on an ageing 2025 base. Consensus 2026 earnings per share has risen 6.4% since January and 4.3% since the H1 results, while the price was flat between the releases until today’s 6% gain: the stock de-rated from 46.4x to 44.0x before the print. The price sits 14% above its 200-day average. At about 33x 2027 analyst estimates, upgrades, not the multiple, drive the next leg.</a:t>
             </a:r>
             <a:endParaRPr lang="en-US" sz="870" dirty="0"/>
           </a:p>

</xml_diff>